<commit_message>
docs: actualizar documentos de sustentacion con cifras y hallazgos corregidos
- Volumetria real de silver y gold (98,6 M filas, 16 GB, hecho de 2.967.681 filas)
- 15 particiones, catalogo silver.language y nombres oficiales de idioma
- Regla de fecha sin imputar con el anio del artista y conteos aditivos
- Conclusion de RF05 basada en los coeficientes de Pearson reales
- Declarar python-pptx en requirements
</commit_message>
<xml_diff>
--- a/docs/DWMusicBrainz_Sustentacion.pptx
+++ b/docs/DWMusicBrainz_Sustentacion.pptx
@@ -3581,7 +3581,7 @@
               </a:defRPr>
             </a:pPr>
             <a:r>
-              <a:t>• ~89,3 M filas Silver | &gt; 14,5 GB en disco.</a:t>
+              <a:t>• ~98,6 M filas Silver | ~16 GB en disco.</a:t>
             </a:r>
           </a:p>
           <a:p>
@@ -3597,7 +3597,7 @@
               </a:defRPr>
             </a:pPr>
             <a:r>
-              <a:t>• 14 Particiones por fecha_key + 4 Vistas Mat.</a:t>
+              <a:t>• 15 Particiones por fecha_key + 4 Vistas Mat.</a:t>
             </a:r>
           </a:p>
           <a:p>
@@ -4431,7 +4431,7 @@
               </a:defRPr>
             </a:pPr>
             <a:r>
-              <a:t>gold.dim_fecha (47.848 filas)</a:t>
+              <a:t>gold.dim_fecha (47.847 filas)</a:t>
             </a:r>
           </a:p>
           <a:p>
@@ -4539,7 +4539,7 @@
               </a:defRPr>
             </a:pPr>
             <a:r>
-              <a:t>gold.dim_artista (3,01 M filas)</a:t>
+              <a:t>gold.dim_artista (3,02 M filas)</a:t>
             </a:r>
           </a:p>
           <a:p>
@@ -4647,7 +4647,7 @@
               </a:defRPr>
             </a:pPr>
             <a:r>
-              <a:t>gold.dim_lanzamiento (~150)</a:t>
+              <a:t>gold.dim_lanzamiento (313)</a:t>
             </a:r>
           </a:p>
           <a:p>
@@ -4755,7 +4755,7 @@
               </a:defRPr>
             </a:pPr>
             <a:r>
-              <a:t>gold.dim_geografia (120.108)</a:t>
+              <a:t>gold.dim_geografia (120.109)</a:t>
             </a:r>
           </a:p>
           <a:p>
@@ -4863,7 +4863,7 @@
               </a:defRPr>
             </a:pPr>
             <a:r>
-              <a:t>gold.dim_formato (114 filas)</a:t>
+              <a:t>gold.dim_formato (115 filas)</a:t>
             </a:r>
           </a:p>
           <a:p>
@@ -5272,7 +5272,7 @@
               </a:defRPr>
             </a:pPr>
             <a:r>
-              <a:t>1. gold.dim_fecha (47.848 filas)</a:t>
+              <a:t>1. gold.dim_fecha (47.847 filas)</a:t>
             </a:r>
           </a:p>
           <a:p>
@@ -5380,7 +5380,7 @@
               </a:defRPr>
             </a:pPr>
             <a:r>
-              <a:t>2. gold.dim_artista (3.010.452 filas)</a:t>
+              <a:t>2. gold.dim_artista (3.015.713 filas)</a:t>
             </a:r>
           </a:p>
           <a:p>
@@ -5488,7 +5488,7 @@
               </a:defRPr>
             </a:pPr>
             <a:r>
-              <a:t>3. gold.dim_lanzamiento (~150 perfiles)</a:t>
+              <a:t>3. gold.dim_lanzamiento (313 perfiles)</a:t>
             </a:r>
           </a:p>
           <a:p>
@@ -5596,7 +5596,7 @@
               </a:defRPr>
             </a:pPr>
             <a:r>
-              <a:t>4. gold.dim_geografia (120.108 filas)</a:t>
+              <a:t>4. gold.dim_geografia (120.109 filas)</a:t>
             </a:r>
           </a:p>
           <a:p>
@@ -5704,7 +5704,7 @@
               </a:defRPr>
             </a:pPr>
             <a:r>
-              <a:t>5. gold.dim_formato (114 filas)</a:t>
+              <a:t>5. gold.dim_formato (115 filas)</a:t>
             </a:r>
           </a:p>
           <a:p>
@@ -5844,7 +5844,7 @@
               </a:defRPr>
             </a:pPr>
             <a:r>
-              <a:t>• Atributos: nombre_idioma ('Inglés', 'Español', 'Japonés', 'Alemán', 'Francés', 'Sin Contenido Lingüístico / Instrumental', 'Múltiples Idiomas'), codigo_iso ('eng', 'spa', 'jpn', 'zxx', 'mul', 'und').</a:t>
+              <a:t>• Atributos: nombre_idioma (nombre oficial del catálogo silver.language: 'English', 'Spanish', 'Japanese', 'German', 'French', '[No linguistic content]', '[Multiple languages]'; clave 0 = 'Idioma No Especificado'), codigo_iso ISO 639-3 ('eng', 'spa', 'jpn', 'zxx', 'mul', 'und').</a:t>
             </a:r>
           </a:p>
           <a:p>
@@ -5860,7 +5860,7 @@
               </a:defRPr>
             </a:pPr>
             <a:r>
-              <a:t>• Rol: Clasificación lingüística oficial ISO 639-3 de los lanzamientos.</a:t>
+              <a:t>• Rol: Clasificación lingüística ISO 639-3, resuelta con JOIN al catálogo oficial silver.language (7.846 idiomas).</a:t>
             </a:r>
           </a:p>
         </p:txBody>
@@ -7272,7 +7272,7 @@
               </a:defRPr>
             </a:pPr>
             <a:r>
-              <a:t>• Ejecuta en orden los 5 archivos DDL:</a:t>
+              <a:t>• Ejecuta en orden los 6 archivos DDL:</a:t>
             </a:r>
           </a:p>
           <a:p>
@@ -7304,7 +7304,7 @@
               </a:defRPr>
             </a:pPr>
             <a:r>
-              <a:t>  2. 02_create_silver_tables.sql (10 tablas)</a:t>
+              <a:t>  2. 02_create_silver_tables.sql (11 tablas)</a:t>
             </a:r>
           </a:p>
           <a:p>
@@ -7336,7 +7336,7 @@
               </a:defRPr>
             </a:pPr>
             <a:r>
-              <a:t>  4. 04_indexes_partitions.sql (14 particiones)</a:t>
+              <a:t>  4. 04_indexes_partitions.sql (15 particiones)</a:t>
             </a:r>
           </a:p>
           <a:p>
@@ -7352,7 +7352,7 @@
               </a:defRPr>
             </a:pPr>
             <a:r>
-              <a:t>  5. 05_aggregations.sql (4 Vistas Mat.)</a:t>
+              <a:t>  5. 05/06: vistas mat. y distribución</a:t>
             </a:r>
           </a:p>
         </p:txBody>
@@ -7708,7 +7708,7 @@
               </a:defRPr>
             </a:pPr>
             <a:r>
-              <a:t>• Puebla en orden las 6 dimensiones conformadas en español (populate_dim_*.sql).</a:t>
+              <a:t>• Puebla las 7 dimensiones (populate_dim_*.sql).</a:t>
             </a:r>
           </a:p>
           <a:p>
@@ -7724,7 +7724,7 @@
               </a:defRPr>
             </a:pPr>
             <a:r>
-              <a:t>• Ejecuta populate_fact_tracks.sql: resuelve fechas reales, artista principal y hace GROUP BY diario con las 11 métricas aditivas.</a:t>
+              <a:t>• populate_fact_tracks.sql agrega por día 11 métricas aditivas; cada lanzamiento cuenta una sola vez.</a:t>
             </a:r>
           </a:p>
           <a:p>
@@ -7740,7 +7740,7 @@
               </a:defRPr>
             </a:pPr>
             <a:r>
-              <a:t>• Refresca las 4 MVs y valida calidad en meta.data_quality_log.</a:t>
+              <a:t>• Puebla el hecho de distribución, refresca las MVs y concilia contra Silver.</a:t>
             </a:r>
           </a:p>
         </p:txBody>
@@ -8237,7 +8237,7 @@
                         </a:defRPr>
                       </a:pPr>
                       <a:r>
-                        <a:t>Prioridad: release_country → release_unknown_country → artist.begin_date_year → 0.</a:t>
+                        <a:t>Prioridad: release_country → release_unknown_country → 0 (Sin Fecha). No se imputa con el año del artista.</a:t>
                       </a:r>
                     </a:p>
                   </a:txBody>
@@ -9021,7 +9021,7 @@
                         </a:defRPr>
                       </a:pPr>
                       <a:r>
-                        <a:t>Ejecución de 7 reglas críticas al cierre de run_gold_pipeline.py.</a:t>
+                        <a:t>Ejecución de 10 reglas críticas al cierre de run_gold_pipeline.py.</a:t>
                       </a:r>
                     </a:p>
                   </a:txBody>
@@ -9340,7 +9340,7 @@
               </a:defRPr>
             </a:pPr>
             <a:r>
-              <a:t>14 Particiones por fecha_key</a:t>
+              <a:t>15 Particiones por fecha_key</a:t>
             </a:r>
           </a:p>
           <a:p>
@@ -9828,7 +9828,7 @@
               </a:defRPr>
             </a:pPr>
             <a:r>
-              <a:t>• Demuestra el acortamiento musical en la era del streaming y la transición Vinilo → CD → Digital.</a:t>
+              <a:t>• Evidencia la transición Vinilo → CD → Digital (el digital supera al CD en 2012) y una duración que crece a largo plazo (r = 0,89) y se acorta desde 2013 (r = -0,57).</a:t>
             </a:r>
           </a:p>
         </p:txBody>
@@ -10237,7 +10237,7 @@
               </a:defRPr>
             </a:pPr>
             <a:r>
-              <a:t>• Se procesaron ~89,3 millones de registros en Silver y se superaron los 14,5 GB en disco, cumpliendo con creces los requisitos no funcionales de estrés.</a:t>
+              <a:t>• Se procesaron ~98,6 millones de registros en Silver y se alcanzaron 16 GB en disco, cumpliendo con creces los requisitos no funcionales de estrés.</a:t>
             </a:r>
           </a:p>
         </p:txBody>
@@ -10329,7 +10329,7 @@
               </a:defRPr>
             </a:pPr>
             <a:r>
-              <a:t>• La auditoría automatizada en meta.etl_audit y meta.data_quality_log asegura trazabilidad de grado empresarial.</a:t>
+              <a:t>• La auditoría automatizada en meta.etl_audit y meta.data_quality_log asegura trazabilidad. Una auditoría posterior detectó y corrigió conteos no aditivos, fechas imputadas con el año del artista y un mapeo de idiomas erróneo.</a:t>
             </a:r>
           </a:p>
         </p:txBody>
@@ -10405,7 +10405,7 @@
               </a:defRPr>
             </a:pPr>
             <a:r>
-              <a:t>• La combinación de particionamiento declarativo por rango en fecha_key (14 particiones) y 4 vistas materializadas permite responder en milisegundos a los requerimientos RF01–RF08.</a:t>
+              <a:t>• La combinación de particionamiento declarativo por rango en fecha_key (15 particiones) y 4 vistas materializadas permite responder en milisegundos a los requerimientos RF01–RF08.</a:t>
             </a:r>
           </a:p>
           <a:p>
@@ -10421,7 +10421,7 @@
               </a:defRPr>
             </a:pPr>
             <a:r>
-              <a:t>• En Power BI se comprueban con evidencia empírica la reducción de la duración musical en la era del streaming, la sustitución tecnológica de formatos físicos por digitales y las brechas regionales de formalización ISRC.</a:t>
+              <a:t>• En Power BI (3 páginas, 26 medidas DAX) se evidencian la sustitución de formatos físicos por digitales (cruce en 2012), una duración que crece a largo plazo y se acorta levemente desde 2013, y las brechas regionales de formalización ISRC.</a:t>
             </a:r>
           </a:p>
         </p:txBody>
@@ -10770,7 +10770,7 @@
               </a:defRPr>
             </a:pPr>
             <a:r>
-              <a:t>  - area (120k), artist (3.01M), artist_credit_name (6.21M).</a:t>
+              <a:t>  - area (120k), artist (3.02M), artist_credit_name (7.30M).</a:t>
             </a:r>
           </a:p>
           <a:p>
@@ -10786,7 +10786,7 @@
               </a:defRPr>
             </a:pPr>
             <a:r>
-              <a:t>  - release (5.84M), release_country (5.48M), release_unknown_country (215k).</a:t>
+              <a:t>  - release (5.86M), release_country (13.34M), release_unknown_country (484k).</a:t>
             </a:r>
           </a:p>
           <a:p>
@@ -10802,7 +10802,7 @@
               </a:defRPr>
             </a:pPr>
             <a:r>
-              <a:t>  - medium (6.41M), recording (40.53M), track (15M), isrc (6.48M).</a:t>
+              <a:t>  - medium (6.43M), recording (40.60M), track (15M), isrc (6.50M).</a:t>
             </a:r>
           </a:p>
           <a:p>
@@ -10818,7 +10818,7 @@
               </a:defRPr>
             </a:pPr>
             <a:r>
-              <a:t>• Total procesado en origen: ~89,3 millones de registros.</a:t>
+              <a:t>• Total procesado en origen: ~98,6 millones de registros.</a:t>
             </a:r>
           </a:p>
         </p:txBody>
@@ -10942,7 +10942,7 @@
               </a:defRPr>
             </a:pPr>
             <a:r>
-              <a:t>• Penalización severa de I/O y RAM: calcular tendencias por década o cobertura ISRC sobre 40,5M de grabaciones y 15M de pistas en 3NF agota la memoria y tarda minutos.</a:t>
+              <a:t>• Penalización severa de I/O y RAM: calcular tendencias por década o cobertura ISRC sobre 40,6M de grabaciones y 15M de pistas en 3NF agota la memoria y tarda minutos.</a:t>
             </a:r>
           </a:p>
           <a:p>
@@ -11098,7 +11098,7 @@
               </a:defRPr>
             </a:pPr>
             <a:r>
-              <a:t>• Particionamiento por rango en fecha_key (14 particiones) + 4 Vistas Materializadas: consultas en &lt; 0,10 s.</a:t>
+              <a:t>• Particionamiento por rango en fecha_key (15 particiones) + 4 Vistas Materializadas: consultas en &lt; 0,10 s.</a:t>
             </a:r>
           </a:p>
         </p:txBody>
@@ -13226,7 +13226,7 @@
                         </a:defRPr>
                       </a:pPr>
                       <a:r>
-                        <a:t>&gt; 14,5 GB consolidados en disco entre capas Silver, Gold y Meta.</a:t>
+                        <a:t>~16 GB consolidados en disco entre capas Silver, Gold y Meta.</a:t>
                       </a:r>
                     </a:p>
                   </a:txBody>
@@ -13348,7 +13348,7 @@
                         </a:defRPr>
                       </a:pPr>
                       <a:r>
-                        <a:t>~89,3 M de filas en Silver (10 tablas) y 15 M de pistas agregadas en Gold.</a:t>
+                        <a:t>~98,6 M de filas en Silver (10 tablas) y 15 M de pistas agregadas en Gold.</a:t>
                       </a:r>
                     </a:p>
                   </a:txBody>
@@ -14447,7 +14447,7 @@
               </a:defRPr>
             </a:pPr>
             <a:r>
-              <a:t>• 10 archivos TSV planos sin encabezados y con nulos representados como \N.</a:t>
+              <a:t>• 11 archivos TSV planos (incluye el catálogo language) sin encabezados y con nulos representados como \N.</a:t>
             </a:r>
           </a:p>
           <a:p>
@@ -14555,7 +14555,7 @@
               </a:defRPr>
             </a:pPr>
             <a:r>
-              <a:t>• 10 tablas normalizadas en 3NF (~89,3 M de filas).</a:t>
+              <a:t>• 10 tablas normalizadas en 3NF (~98,6 M de filas).</a:t>
             </a:r>
           </a:p>
           <a:p>
@@ -14835,7 +14835,7 @@
               </a:defRPr>
             </a:pPr>
             <a:r>
-              <a:t>• Conexión a localhost:5435 (esquema gold).</a:t>
+              <a:t>• Conexión a PostgreSQL (esquema gold) en modo Import.</a:t>
             </a:r>
           </a:p>
           <a:p>
@@ -15439,7 +15439,7 @@
                         </a:defRPr>
                       </a:pPr>
                       <a:r>
-                        <a:t>• Automatizar las 7 pruebas de calidad en meta.data_quality_log.</a:t>
+                        <a:t>• Automatizar las 10 pruebas de calidad en meta.data_quality_log.</a:t>
                       </a:r>
                     </a:p>
                   </a:txBody>
@@ -15476,7 +15476,7 @@
                         </a:defRPr>
                       </a:pPr>
                       <a:r>
-                        <a:t>• Auditar la huella física en disco (&gt; 14,5 GB) y tiempos de ejecución con scripts/verify_dwh.py.</a:t>
+                        <a:t>• Auditar la huella física en disco (~16 GB) y tiempos de ejecución con scripts/verify_dwh.py.</a:t>
                       </a:r>
                     </a:p>
                   </a:txBody>
@@ -15626,7 +15626,7 @@
                         </a:defRPr>
                       </a:pPr>
                       <a:r>
-                        <a:t>• Diseñar las 14 particiones físicas por rango en fecha_key (04_indexes_partitions.sql) y los índices B-Tree.</a:t>
+                        <a:t>• Diseñar las 15 particiones físicas por rango en fecha_key (04_indexes_partitions.sql) y los índices B-Tree.</a:t>
                       </a:r>
                     </a:p>
                     <a:p>
@@ -17105,7 +17105,7 @@
               </a:defRPr>
             </a:pPr>
             <a:r>
-              <a:t>Consolidado de las 10 tablas de la capa Silver (~89,3 M de filas) y las entidades del Modelo Estrella en Gold (&gt; 14,5 GB)</a:t>
+              <a:t>Consolidado de las 10 tablas de la capa Silver (~98,6 M de filas) y las entidades del Modelo Estrella en Gold (~16 GB)</a:t>
             </a:r>
           </a:p>
         </p:txBody>
@@ -17307,7 +17307,7 @@
                         </a:defRPr>
                       </a:pPr>
                       <a:r>
-                        <a:t>40.532.448</a:t>
+                        <a:t>40.595.893</a:t>
                       </a:r>
                     </a:p>
                   </a:txBody>
@@ -17331,7 +17331,7 @@
                         </a:defRPr>
                       </a:pPr>
                       <a:r>
-                        <a:t>4.998 MB</a:t>
+                        <a:t>5.854 MB</a:t>
                       </a:r>
                     </a:p>
                   </a:txBody>
@@ -17429,7 +17429,7 @@
                         </a:defRPr>
                       </a:pPr>
                       <a:r>
-                        <a:t>1.967 MB</a:t>
+                        <a:t>2.865 MB</a:t>
                       </a:r>
                     </a:p>
                   </a:txBody>
@@ -17503,7 +17503,7 @@
                         </a:defRPr>
                       </a:pPr>
                       <a:r>
-                        <a:t>6.478.709</a:t>
+                        <a:t>6.502.252</a:t>
                       </a:r>
                     </a:p>
                   </a:txBody>
@@ -17527,7 +17527,7 @@
                         </a:defRPr>
                       </a:pPr>
                       <a:r>
-                        <a:t>795 MB</a:t>
+                        <a:t>798 MB</a:t>
                       </a:r>
                     </a:p>
                   </a:txBody>
@@ -17601,7 +17601,7 @@
                         </a:defRPr>
                       </a:pPr>
                       <a:r>
-                        <a:t>6.411.799</a:t>
+                        <a:t>6.426.136</a:t>
                       </a:r>
                     </a:p>
                   </a:txBody>
@@ -17625,7 +17625,7 @@
                         </a:defRPr>
                       </a:pPr>
                       <a:r>
-                        <a:t>986 MB</a:t>
+                        <a:t>988 MB</a:t>
                       </a:r>
                     </a:p>
                   </a:txBody>
@@ -17699,7 +17699,7 @@
                         </a:defRPr>
                       </a:pPr>
                       <a:r>
-                        <a:t>~6.210.000</a:t>
+                        <a:t>7.301.698</a:t>
                       </a:r>
                     </a:p>
                   </a:txBody>
@@ -17723,7 +17723,7 @@
                         </a:defRPr>
                       </a:pPr>
                       <a:r>
-                        <a:t>420 MB</a:t>
+                        <a:t>741 MB</a:t>
                       </a:r>
                     </a:p>
                   </a:txBody>
@@ -17797,7 +17797,7 @@
                         </a:defRPr>
                       </a:pPr>
                       <a:r>
-                        <a:t>5.844.569</a:t>
+                        <a:t>5.858.206</a:t>
                       </a:r>
                     </a:p>
                   </a:txBody>
@@ -17821,7 +17821,7 @@
                         </a:defRPr>
                       </a:pPr>
                       <a:r>
-                        <a:t>1.108 MB</a:t>
+                        <a:t>1.110 MB</a:t>
                       </a:r>
                     </a:p>
                   </a:txBody>
@@ -17895,7 +17895,7 @@
                         </a:defRPr>
                       </a:pPr>
                       <a:r>
-                        <a:t>~5.480.000</a:t>
+                        <a:t>13.337.269</a:t>
                       </a:r>
                     </a:p>
                   </a:txBody>
@@ -17919,7 +17919,7 @@
                         </a:defRPr>
                       </a:pPr>
                       <a:r>
-                        <a:t>385 MB</a:t>
+                        <a:t>1.299 MB</a:t>
                       </a:r>
                     </a:p>
                   </a:txBody>
@@ -17993,7 +17993,7 @@
                         </a:defRPr>
                       </a:pPr>
                       <a:r>
-                        <a:t>3.010.451</a:t>
+                        <a:t>3.015.712</a:t>
                       </a:r>
                     </a:p>
                   </a:txBody>
@@ -18017,7 +18017,7 @@
                         </a:defRPr>
                       </a:pPr>
                       <a:r>
-                        <a:t>498 MB</a:t>
+                        <a:t>499 MB</a:t>
                       </a:r>
                     </a:p>
                   </a:txBody>
@@ -18091,7 +18091,7 @@
                         </a:defRPr>
                       </a:pPr>
                       <a:r>
-                        <a:t>~215.000</a:t>
+                        <a:t>484.343</a:t>
                       </a:r>
                     </a:p>
                   </a:txBody>
@@ -18115,7 +18115,7 @@
                         </a:defRPr>
                       </a:pPr>
                       <a:r>
-                        <a:t>18 MB</a:t>
+                        <a:t>36 MB</a:t>
                       </a:r>
                     </a:p>
                   </a:txBody>
@@ -18189,7 +18189,7 @@
                         </a:defRPr>
                       </a:pPr>
                       <a:r>
-                        <a:t>120.107</a:t>
+                        <a:t>120.108</a:t>
                       </a:r>
                     </a:p>
                   </a:txBody>
@@ -18213,7 +18213,7 @@
                         </a:defRPr>
                       </a:pPr>
                       <a:r>
-                        <a:t>14 MB</a:t>
+                        <a:t>16 MB</a:t>
                       </a:r>
                     </a:p>
                   </a:txBody>
@@ -18287,7 +18287,7 @@
                         </a:defRPr>
                       </a:pPr>
                       <a:r>
-                        <a:t>~89.303.083</a:t>
+                        <a:t>98.641.617</a:t>
                       </a:r>
                     </a:p>
                   </a:txBody>
@@ -18311,7 +18311,7 @@
                         </a:defRPr>
                       </a:pPr>
                       <a:r>
-                        <a:t>~11.189 MB</a:t>
+                        <a:t>14.206 MB</a:t>
                       </a:r>
                     </a:p>
                   </a:txBody>
@@ -18511,7 +18511,7 @@
                         </a:defRPr>
                       </a:pPr>
                       <a:r>
-                        <a:t>~4,5M – 5,8M</a:t>
+                        <a:t>2.967.681</a:t>
                       </a:r>
                     </a:p>
                   </a:txBody>
@@ -18535,7 +18535,7 @@
                         </a:defRPr>
                       </a:pPr>
                       <a:r>
-                        <a:t>~2.450 MB</a:t>
+                        <a:t>570 MB</a:t>
                       </a:r>
                     </a:p>
                   </a:txBody>
@@ -18609,7 +18609,7 @@
                         </a:defRPr>
                       </a:pPr>
                       <a:r>
-                        <a:t>3.010.452</a:t>
+                        <a:t>3.015.713</a:t>
                       </a:r>
                     </a:p>
                   </a:txBody>
@@ -18633,7 +18633,7 @@
                         </a:defRPr>
                       </a:pPr>
                       <a:r>
-                        <a:t>758 MB</a:t>
+                        <a:t>1.476 MB</a:t>
                       </a:r>
                     </a:p>
                   </a:txBody>
@@ -18707,7 +18707,7 @@
                         </a:defRPr>
                       </a:pPr>
                       <a:r>
-                        <a:t>120.108</a:t>
+                        <a:t>120.109</a:t>
                       </a:r>
                     </a:p>
                   </a:txBody>
@@ -18731,7 +18731,7 @@
                         </a:defRPr>
                       </a:pPr>
                       <a:r>
-                        <a:t>15 MB</a:t>
+                        <a:t>19 MB</a:t>
                       </a:r>
                     </a:p>
                   </a:txBody>
@@ -18805,7 +18805,7 @@
                         </a:defRPr>
                       </a:pPr>
                       <a:r>
-                        <a:t>47.848</a:t>
+                        <a:t>47.847</a:t>
                       </a:r>
                     </a:p>
                   </a:txBody>
@@ -18829,7 +18829,7 @@
                         </a:defRPr>
                       </a:pPr>
                       <a:r>
-                        <a:t>4 MB</a:t>
+                        <a:t>6 MB</a:t>
                       </a:r>
                     </a:p>
                   </a:txBody>
@@ -19001,7 +19001,7 @@
                         </a:defRPr>
                       </a:pPr>
                       <a:r>
-                        <a:t>~150</a:t>
+                        <a:t>313</a:t>
                       </a:r>
                     </a:p>
                   </a:txBody>
@@ -19099,7 +19099,7 @@
                         </a:defRPr>
                       </a:pPr>
                       <a:r>
-                        <a:t>114</a:t>
+                        <a:t>115</a:t>
                       </a:r>
                     </a:p>
                   </a:txBody>
@@ -19197,7 +19197,7 @@
                         </a:defRPr>
                       </a:pPr>
                       <a:r>
-                        <a:t>~1.850.000</a:t>
+                        <a:t>690.454</a:t>
                       </a:r>
                     </a:p>
                   </a:txBody>
@@ -19221,7 +19221,7 @@
                         </a:defRPr>
                       </a:pPr>
                       <a:r>
-                        <a:t>165 MB</a:t>
+                        <a:t>131 MB</a:t>
                       </a:r>
                     </a:p>
                   </a:txBody>
@@ -19295,7 +19295,7 @@
                         </a:defRPr>
                       </a:pPr>
                       <a:r>
-                        <a:t>~10.477</a:t>
+                        <a:t>4.711</a:t>
                       </a:r>
                     </a:p>
                   </a:txBody>
@@ -19319,7 +19319,7 @@
                         </a:defRPr>
                       </a:pPr>
                       <a:r>
-                        <a:t>&lt; 3 MB</a:t>
+                        <a:t>&lt; 1 MB</a:t>
                       </a:r>
                     </a:p>
                   </a:txBody>
@@ -19429,7 +19429,7 @@
               </a:defRPr>
             </a:pPr>
             <a:r>
-              <a:t>Huella Total &gt; 14,5 GB en PostgreSQL 16 (Meta: &gt; 3,0 GB)</a:t>
+              <a:t>Huella Total ~16 GB en PostgreSQL 16 (Meta: &gt; 3,0 GB)</a:t>
             </a:r>
           </a:p>
           <a:p>
@@ -19445,7 +19445,7 @@
               </a:defRPr>
             </a:pPr>
             <a:r>
-              <a:t>• Supera en casi 500% el umbral mínimo de almacenamiento físico exigido.</a:t>
+              <a:t>• Supera más de 5 veces el umbral mínimo de almacenamiento físico exigido.</a:t>
             </a:r>
           </a:p>
           <a:p>
@@ -19461,7 +19461,7 @@
               </a:defRPr>
             </a:pPr>
             <a:r>
-              <a:t>• Al modelar dim_lanzamiento por perfil (~150 filas en vez de 5,8M), Power BI opera en memoria con máxima compresión.</a:t>
+              <a:t>• Al modelar dim_lanzamiento por perfil (313 filas en vez de 5,8M), Power BI opera en memoria con máxima compresión.</a:t>
             </a:r>
           </a:p>
         </p:txBody>

</xml_diff>